<commit_message>
Traduction du livret en anglais, ainsi que du matériel qui a changé
</commit_message>
<xml_diff>
--- a/pictures/Memos/memo-en.pptx
+++ b/pictures/Memos/memo-en.pptx
@@ -197,7 +197,7 @@
           <a:p>
             <a:fld id="{849D895D-661B-479D-A688-27E503324CF6}" type="datetimeFigureOut">
               <a:rPr lang="fr-FR" smtClean="0"/>
-              <a:t>05/07/2026</a:t>
+              <a:t>03/10/2026</a:t>
             </a:fld>
             <a:endParaRPr lang="fr-FR"/>
           </a:p>
@@ -679,7 +679,7 @@
           <a:p>
             <a:fld id="{017B969D-5DBB-4D98-A8ED-E39D79CDECF7}" type="datetimeFigureOut">
               <a:rPr lang="fr-FR" smtClean="0"/>
-              <a:t>05/07/2026</a:t>
+              <a:t>03/10/2026</a:t>
             </a:fld>
             <a:endParaRPr lang="fr-FR"/>
           </a:p>
@@ -849,7 +849,7 @@
           <a:p>
             <a:fld id="{017B969D-5DBB-4D98-A8ED-E39D79CDECF7}" type="datetimeFigureOut">
               <a:rPr lang="fr-FR" smtClean="0"/>
-              <a:t>05/07/2026</a:t>
+              <a:t>03/10/2026</a:t>
             </a:fld>
             <a:endParaRPr lang="fr-FR"/>
           </a:p>
@@ -1029,7 +1029,7 @@
           <a:p>
             <a:fld id="{017B969D-5DBB-4D98-A8ED-E39D79CDECF7}" type="datetimeFigureOut">
               <a:rPr lang="fr-FR" smtClean="0"/>
-              <a:t>05/07/2026</a:t>
+              <a:t>03/10/2026</a:t>
             </a:fld>
             <a:endParaRPr lang="fr-FR"/>
           </a:p>
@@ -1199,7 +1199,7 @@
           <a:p>
             <a:fld id="{017B969D-5DBB-4D98-A8ED-E39D79CDECF7}" type="datetimeFigureOut">
               <a:rPr lang="fr-FR" smtClean="0"/>
-              <a:t>05/07/2026</a:t>
+              <a:t>03/10/2026</a:t>
             </a:fld>
             <a:endParaRPr lang="fr-FR"/>
           </a:p>
@@ -1445,7 +1445,7 @@
           <a:p>
             <a:fld id="{017B969D-5DBB-4D98-A8ED-E39D79CDECF7}" type="datetimeFigureOut">
               <a:rPr lang="fr-FR" smtClean="0"/>
-              <a:t>05/07/2026</a:t>
+              <a:t>03/10/2026</a:t>
             </a:fld>
             <a:endParaRPr lang="fr-FR"/>
           </a:p>
@@ -1677,7 +1677,7 @@
           <a:p>
             <a:fld id="{017B969D-5DBB-4D98-A8ED-E39D79CDECF7}" type="datetimeFigureOut">
               <a:rPr lang="fr-FR" smtClean="0"/>
-              <a:t>05/07/2026</a:t>
+              <a:t>03/10/2026</a:t>
             </a:fld>
             <a:endParaRPr lang="fr-FR"/>
           </a:p>
@@ -2044,7 +2044,7 @@
           <a:p>
             <a:fld id="{017B969D-5DBB-4D98-A8ED-E39D79CDECF7}" type="datetimeFigureOut">
               <a:rPr lang="fr-FR" smtClean="0"/>
-              <a:t>05/07/2026</a:t>
+              <a:t>03/10/2026</a:t>
             </a:fld>
             <a:endParaRPr lang="fr-FR"/>
           </a:p>
@@ -2162,7 +2162,7 @@
           <a:p>
             <a:fld id="{017B969D-5DBB-4D98-A8ED-E39D79CDECF7}" type="datetimeFigureOut">
               <a:rPr lang="fr-FR" smtClean="0"/>
-              <a:t>05/07/2026</a:t>
+              <a:t>03/10/2026</a:t>
             </a:fld>
             <a:endParaRPr lang="fr-FR"/>
           </a:p>
@@ -2257,7 +2257,7 @@
           <a:p>
             <a:fld id="{017B969D-5DBB-4D98-A8ED-E39D79CDECF7}" type="datetimeFigureOut">
               <a:rPr lang="fr-FR" smtClean="0"/>
-              <a:t>05/07/2026</a:t>
+              <a:t>03/10/2026</a:t>
             </a:fld>
             <a:endParaRPr lang="fr-FR"/>
           </a:p>
@@ -2534,7 +2534,7 @@
           <a:p>
             <a:fld id="{017B969D-5DBB-4D98-A8ED-E39D79CDECF7}" type="datetimeFigureOut">
               <a:rPr lang="fr-FR" smtClean="0"/>
-              <a:t>05/07/2026</a:t>
+              <a:t>03/10/2026</a:t>
             </a:fld>
             <a:endParaRPr lang="fr-FR"/>
           </a:p>
@@ -2791,7 +2791,7 @@
           <a:p>
             <a:fld id="{017B969D-5DBB-4D98-A8ED-E39D79CDECF7}" type="datetimeFigureOut">
               <a:rPr lang="fr-FR" smtClean="0"/>
-              <a:t>05/07/2026</a:t>
+              <a:t>03/10/2026</a:t>
             </a:fld>
             <a:endParaRPr lang="fr-FR"/>
           </a:p>
@@ -3004,7 +3004,7 @@
           <a:p>
             <a:fld id="{017B969D-5DBB-4D98-A8ED-E39D79CDECF7}" type="datetimeFigureOut">
               <a:rPr lang="fr-FR" smtClean="0"/>
-              <a:t>05/07/2026</a:t>
+              <a:t>03/10/2026</a:t>
             </a:fld>
             <a:endParaRPr lang="fr-FR"/>
           </a:p>
@@ -4853,10 +4853,10 @@
       </p:sp>
       <p:pic>
         <p:nvPicPr>
-          <p:cNvPr id="30" name="Image 29">
+          <p:cNvPr id="2" name="Image 1">
             <a:extLst>
               <a:ext uri="{FF2B5EF4-FFF2-40B4-BE49-F238E27FC236}">
-                <a16:creationId xmlns:a16="http://schemas.microsoft.com/office/drawing/2014/main" id="{29C9C883-A08C-1143-0123-132D70CFA9B9}"/>
+                <a16:creationId xmlns:a16="http://schemas.microsoft.com/office/drawing/2014/main" id="{1AFED1F8-63E7-7016-0CCD-B1068546F375}"/>
               </a:ext>
             </a:extLst>
           </p:cNvPr>
@@ -4873,15 +4873,15 @@
               </a:ext>
             </a:extLst>
           </a:blip>
-          <a:srcRect l="37488" r="37446" b="24600"/>
+          <a:srcRect l="36257" r="36347" b="24920"/>
           <a:stretch>
             <a:fillRect/>
           </a:stretch>
         </p:blipFill>
         <p:spPr bwMode="auto">
           <a:xfrm>
-            <a:off x="2287455" y="8827695"/>
-            <a:ext cx="4831468" cy="1627479"/>
+            <a:off x="2319008" y="8962638"/>
+            <a:ext cx="4366122" cy="1340029"/>
           </a:xfrm>
           <a:prstGeom prst="rect">
             <a:avLst/>

</xml_diff>